<commit_message>
changed the metric from Confusion
</commit_message>
<xml_diff>
--- a/Task_4/Presentation_Task4.pptx
+++ b/Task_4/Presentation_Task4.pptx
@@ -274,7 +274,7 @@
           <a:p>
             <a:fld id="{75AB4CA9-CCE6-4DE5-84AD-E1F7B6CB5CBB}" type="datetimeFigureOut">
               <a:rPr lang="de-DE" smtClean="0"/>
-              <a:t>22.07.2026</a:t>
+              <a:t>23.07.2026</a:t>
             </a:fld>
             <a:endParaRPr lang="de-DE"/>
           </a:p>
@@ -451,7 +451,7 @@
           <a:p>
             <a:fld id="{52D5829F-2F94-0B44-A96D-AE852A87AC61}" type="datetimeFigureOut">
               <a:rPr lang="de-DE" smtClean="0"/>
-              <a:t>22.07.2026</a:t>
+              <a:t>23.07.2026</a:t>
             </a:fld>
             <a:endParaRPr lang="de-DE"/>
           </a:p>

</xml_diff>

<commit_message>
changed Metrics and label like in lecture
</commit_message>
<xml_diff>
--- a/Task_4/Presentation_Task4.pptx
+++ b/Task_4/Presentation_Task4.pptx
@@ -2015,7 +2015,7 @@
                 <a:ea typeface="+mn-ea"/>
                 <a:cs typeface="+mn-cs"/>
               </a:rPr>
-              <a:t>TPR = True positive Rate</a:t>
+              <a:t>TNR = True negative Rate</a:t>
             </a:r>
             <a:endParaRPr lang="de-DE" dirty="0"/>
           </a:p>
@@ -2683,29 +2683,6 @@
                 <a:cs typeface="+mn-cs"/>
               </a:rPr>
               <a:t>Die Feature-Extraktion wird immer vor der Mittelung ausgeführt. Dadurch mitteln wir Merkmalsvektoren und nicht Rohsignale. Die Mittelung verändert nur Z01 und Z04; die anderen Gruppen bleiben inhaltlich unverändert.</a:t>
-            </a:r>
-            <a:br>
-              <a:rPr lang="de-DE" sz="1200" b="0" kern="1200" dirty="0">
-                <a:solidFill>
-                  <a:schemeClr val="tx1"/>
-                </a:solidFill>
-                <a:effectLst/>
-                <a:latin typeface="+mn-lt"/>
-                <a:ea typeface="+mn-ea"/>
-                <a:cs typeface="+mn-cs"/>
-              </a:rPr>
-            </a:br>
-            <a:r>
-              <a:rPr lang="de-DE" sz="1200" b="0" kern="1200" dirty="0">
-                <a:solidFill>
-                  <a:schemeClr val="tx1"/>
-                </a:solidFill>
-                <a:effectLst/>
-                <a:latin typeface="+mn-lt"/>
-                <a:ea typeface="+mn-ea"/>
-                <a:cs typeface="+mn-cs"/>
-              </a:rPr>
-              <a:t>Label deshalb gedreht (zu Task 3), da wir True werden wenn unser Model ein anomales Zahnrad findet.</a:t>
             </a:r>
           </a:p>
           <a:p>
@@ -7905,7 +7882,7 @@
             </a:r>
             <a:r>
               <a:rPr lang="de-DE" dirty="0"/>
-              <a:t> beide Pipelines erreichen in jedem Fold eine TPR von </a:t>
+              <a:t> beide Pipelines erreichen in jedem Fold eine TNR von </a:t>
             </a:r>
             <a:r>
               <a:rPr lang="de-DE" b="1" dirty="0"/>
@@ -7934,21 +7911,16 @@
             </a:pPr>
             <a:r>
               <a:rPr lang="de-DE" b="1" dirty="0" err="1"/>
-              <a:t>mID-Mittlung</a:t>
+              <a:t>mID</a:t>
             </a:r>
             <a:r>
               <a:rPr lang="de-DE" b="1" dirty="0"/>
-              <a:t>: </a:t>
+              <a:t>-Mittelung: </a:t>
             </a:r>
             <a:r>
               <a:rPr lang="de-DE" dirty="0"/>
-              <a:t>Fold 1 kommt auf ähnliche Werte wie Fold 3 Einzelmessung hat aber weniger Daten für das Training durch die </a:t>
-            </a:r>
-            <a:r>
-              <a:rPr lang="de-DE" dirty="0" err="1"/>
-              <a:t>Mittlung</a:t>
-            </a:r>
-            <a:endParaRPr lang="de-DE" dirty="0"/>
+              <a:t>Fold 1 kommt auf ähnliche Werte wie Fold 3 Einzelmessung hat aber weniger Daten für das Training durch die Mittelung</a:t>
+            </a:r>
           </a:p>
           <a:p>
             <a:pPr>
@@ -7961,7 +7933,7 @@
             </a:r>
             <a:r>
               <a:rPr lang="de-DE" dirty="0"/>
-              <a:t>in der Einzelmessung erkennen wir, dass Fold 1 und Fold 4 durch viele Testfälle und wenige Trainings Signale viele FP gefunden werden </a:t>
+              <a:t>in der Einzelmessung erkennen wir, dass Fold 1 und Fold 4 durch viele Testfälle und wenige Trainings Signale viele FN gefunden werden </a:t>
             </a:r>
           </a:p>
           <a:p>
@@ -7971,7 +7943,7 @@
             </a:pPr>
             <a:r>
               <a:rPr lang="de-DE" dirty="0"/>
-              <a:t>Vor allem Fold 4 mit den sehr verteilten Messungen durch Z01 im Testfall erkennt sehr viele FP</a:t>
+              <a:t>Vor allem Fold 4 mit den sehr verteilten Messungen durch Z01 im Testfall erkennt sehr viele FN</a:t>
             </a:r>
           </a:p>
         </p:txBody>
@@ -8274,7 +8246,7 @@
           <p:nvPr>
             <p:extLst>
               <p:ext uri="{D42A27DB-BD31-4B8C-83A1-F6EECF244321}">
-                <p14:modId xmlns:p14="http://schemas.microsoft.com/office/powerpoint/2010/main" val="2350955294"/>
+                <p14:modId xmlns:p14="http://schemas.microsoft.com/office/powerpoint/2010/main" val="1757277997"/>
               </p:ext>
             </p:extLst>
           </p:nvPr>
@@ -8472,7 +8444,7 @@
                     <a:p>
                       <a:r>
                         <a:rPr lang="de-DE" dirty="0"/>
-                        <a:t>1.00</a:t>
+                        <a:t>0.875</a:t>
                       </a:r>
                     </a:p>
                   </a:txBody>
@@ -8489,7 +8461,7 @@
                     <a:p>
                       <a:r>
                         <a:rPr lang="de-DE" dirty="0"/>
-                        <a:t>0.875</a:t>
+                        <a:t>1.00</a:t>
                       </a:r>
                     </a:p>
                   </a:txBody>
@@ -8581,7 +8553,7 @@
                     <a:p>
                       <a:r>
                         <a:rPr lang="de-DE" dirty="0"/>
-                        <a:t>1.00</a:t>
+                        <a:t>0.875</a:t>
                       </a:r>
                     </a:p>
                   </a:txBody>
@@ -8598,7 +8570,7 @@
                     <a:p>
                       <a:r>
                         <a:rPr lang="de-DE" dirty="0"/>
-                        <a:t>0.875</a:t>
+                        <a:t>1.00</a:t>
                       </a:r>
                     </a:p>
                   </a:txBody>
@@ -8690,7 +8662,7 @@
                     <a:p>
                       <a:r>
                         <a:rPr lang="de-DE" dirty="0"/>
-                        <a:t>1.00</a:t>
+                        <a:t>0.950</a:t>
                       </a:r>
                     </a:p>
                   </a:txBody>
@@ -8707,7 +8679,7 @@
                     <a:p>
                       <a:r>
                         <a:rPr lang="de-DE" dirty="0"/>
-                        <a:t>0.950</a:t>
+                        <a:t>1.00</a:t>
                       </a:r>
                     </a:p>
                   </a:txBody>
@@ -8799,7 +8771,7 @@
                     <a:p>
                       <a:r>
                         <a:rPr lang="de-DE" dirty="0"/>
-                        <a:t>1.00</a:t>
+                        <a:t>0.510</a:t>
                       </a:r>
                     </a:p>
                   </a:txBody>
@@ -8816,7 +8788,7 @@
                     <a:p>
                       <a:r>
                         <a:rPr lang="de-DE" dirty="0"/>
-                        <a:t>0.510</a:t>
+                        <a:t>1.00</a:t>
                       </a:r>
                     </a:p>
                   </a:txBody>
@@ -9359,7 +9331,7 @@
             </a:r>
             <a:r>
               <a:rPr lang="de-DE" b="1" dirty="0"/>
-              <a:t>gesund (Label 0)</a:t>
+              <a:t>gesund (Label 1)</a:t>
             </a:r>
             <a:r>
               <a:rPr lang="de-DE" dirty="0"/>
@@ -9374,7 +9346,7 @@
             </a:r>
             <a:r>
               <a:rPr lang="de-DE" b="1" dirty="0"/>
-              <a:t>anomal (Label 1)</a:t>
+              <a:t>anomal (Label 0)</a:t>
             </a:r>
             <a:endParaRPr lang="de-DE" dirty="0"/>
           </a:p>
@@ -10514,7 +10486,7 @@
             </a:pPr>
             <a:r>
               <a:rPr lang="de-DE" dirty="0"/>
-              <a:t>Training ausschließlich mit Label 0</a:t>
+              <a:t>Training ausschließlich mit Label 1</a:t>
             </a:r>
           </a:p>
         </p:txBody>
@@ -10760,7 +10732,7 @@
             </a:pPr>
             <a:r>
               <a:rPr lang="de-DE" dirty="0"/>
-              <a:t>oberhalb der Schwelle: anomal (Label 1)</a:t>
+              <a:t>oberhalb der Schwelle: anomal (Label 0)</a:t>
             </a:r>
           </a:p>
           <a:p>
@@ -11052,7 +11024,7 @@
             <p:ph sz="quarter" idx="14"/>
             <p:extLst>
               <p:ext uri="{D42A27DB-BD31-4B8C-83A1-F6EECF244321}">
-                <p14:modId xmlns:p14="http://schemas.microsoft.com/office/powerpoint/2010/main" val="1025093787"/>
+                <p14:modId xmlns:p14="http://schemas.microsoft.com/office/powerpoint/2010/main" val="1226952282"/>
               </p:ext>
             </p:extLst>
           </p:nvPr>
@@ -11444,7 +11416,21 @@
                       <a:pPr algn="ctr"/>
                       <a:r>
                         <a:rPr lang="de-DE" dirty="0"/>
-                        <a:t>1.00</a:t>
+                        <a:t>0.867</a:t>
+                      </a:r>
+                    </a:p>
+                  </a:txBody>
+                  <a:tcPr/>
+                </a:tc>
+                <a:tc>
+                  <a:txBody>
+                    <a:bodyPr/>
+                    <a:lstStyle/>
+                    <a:p>
+                      <a:pPr algn="ctr"/>
+                      <a:r>
+                        <a:rPr lang="de-DE" dirty="0"/>
+                        <a:t>0.883</a:t>
                       </a:r>
                     </a:p>
                   </a:txBody>
@@ -11472,21 +11458,7 @@
                       <a:pPr algn="ctr"/>
                       <a:r>
                         <a:rPr lang="de-DE" dirty="0"/>
-                        <a:t>0.867</a:t>
-                      </a:r>
-                    </a:p>
-                  </a:txBody>
-                  <a:tcPr/>
-                </a:tc>
-                <a:tc>
-                  <a:txBody>
-                    <a:bodyPr/>
-                    <a:lstStyle/>
-                    <a:p>
-                      <a:pPr algn="ctr"/>
-                      <a:r>
-                        <a:rPr lang="de-DE" dirty="0"/>
-                        <a:t>0.883</a:t>
+                        <a:t>1.00</a:t>
                       </a:r>
                     </a:p>
                   </a:txBody>
@@ -11549,7 +11521,21 @@
                       <a:pPr algn="ctr"/>
                       <a:r>
                         <a:rPr lang="de-DE" dirty="0"/>
-                        <a:t>1.00</a:t>
+                        <a:t>0.900</a:t>
+                      </a:r>
+                    </a:p>
+                  </a:txBody>
+                  <a:tcPr/>
+                </a:tc>
+                <a:tc>
+                  <a:txBody>
+                    <a:bodyPr/>
+                    <a:lstStyle/>
+                    <a:p>
+                      <a:pPr algn="ctr"/>
+                      <a:r>
+                        <a:rPr lang="de-DE" dirty="0"/>
+                        <a:t>0.850</a:t>
                       </a:r>
                     </a:p>
                   </a:txBody>
@@ -11577,21 +11563,7 @@
                       <a:pPr algn="ctr"/>
                       <a:r>
                         <a:rPr lang="de-DE" dirty="0"/>
-                        <a:t>0.900</a:t>
-                      </a:r>
-                    </a:p>
-                  </a:txBody>
-                  <a:tcPr/>
-                </a:tc>
-                <a:tc>
-                  <a:txBody>
-                    <a:bodyPr/>
-                    <a:lstStyle/>
-                    <a:p>
-                      <a:pPr algn="ctr"/>
-                      <a:r>
-                        <a:rPr lang="de-DE" dirty="0"/>
-                        <a:t>0.850</a:t>
+                        <a:t>1.00</a:t>
                       </a:r>
                     </a:p>
                   </a:txBody>
@@ -11654,7 +11626,21 @@
                       <a:pPr algn="ctr"/>
                       <a:r>
                         <a:rPr lang="de-DE" dirty="0"/>
-                        <a:t>1.00</a:t>
+                        <a:t>0.950</a:t>
+                      </a:r>
+                    </a:p>
+                  </a:txBody>
+                  <a:tcPr/>
+                </a:tc>
+                <a:tc>
+                  <a:txBody>
+                    <a:bodyPr/>
+                    <a:lstStyle/>
+                    <a:p>
+                      <a:pPr algn="ctr"/>
+                      <a:r>
+                        <a:rPr lang="de-DE" dirty="0"/>
+                        <a:t>0.950</a:t>
                       </a:r>
                     </a:p>
                   </a:txBody>
@@ -11682,21 +11668,7 @@
                       <a:pPr algn="ctr"/>
                       <a:r>
                         <a:rPr lang="de-DE" dirty="0"/>
-                        <a:t>0.950</a:t>
-                      </a:r>
-                    </a:p>
-                  </a:txBody>
-                  <a:tcPr/>
-                </a:tc>
-                <a:tc>
-                  <a:txBody>
-                    <a:bodyPr/>
-                    <a:lstStyle/>
-                    <a:p>
-                      <a:pPr algn="ctr"/>
-                      <a:r>
-                        <a:rPr lang="de-DE" dirty="0"/>
-                        <a:t>0.950</a:t>
+                        <a:t>1.00</a:t>
                       </a:r>
                     </a:p>
                   </a:txBody>
@@ -11759,7 +11731,21 @@
                       <a:pPr algn="ctr"/>
                       <a:r>
                         <a:rPr lang="de-DE" dirty="0"/>
-                        <a:t>1.00</a:t>
+                        <a:t>0.290</a:t>
+                      </a:r>
+                    </a:p>
+                  </a:txBody>
+                  <a:tcPr/>
+                </a:tc>
+                <a:tc>
+                  <a:txBody>
+                    <a:bodyPr/>
+                    <a:lstStyle/>
+                    <a:p>
+                      <a:pPr algn="ctr"/>
+                      <a:r>
+                        <a:rPr lang="de-DE" dirty="0"/>
+                        <a:t>0.730</a:t>
                       </a:r>
                     </a:p>
                   </a:txBody>
@@ -11787,21 +11773,7 @@
                       <a:pPr algn="ctr"/>
                       <a:r>
                         <a:rPr lang="de-DE" dirty="0"/>
-                        <a:t>0.290</a:t>
-                      </a:r>
-                    </a:p>
-                  </a:txBody>
-                  <a:tcPr/>
-                </a:tc>
-                <a:tc>
-                  <a:txBody>
-                    <a:bodyPr/>
-                    <a:lstStyle/>
-                    <a:p>
-                      <a:pPr algn="ctr"/>
-                      <a:r>
-                        <a:rPr lang="de-DE" dirty="0"/>
-                        <a:t>0.730</a:t>
+                        <a:t>1.00</a:t>
                       </a:r>
                     </a:p>
                   </a:txBody>

</xml_diff>